<commit_message>
Updated to correct for the new number of elite-alpha insiders after grouping for transactions that occured in the same month
</commit_message>
<xml_diff>
--- a/02-tmacphe-kirtland-ramiab-KB.pptx
+++ b/02-tmacphe-kirtland-ramiab-KB.pptx
@@ -288,10 +288,39 @@
       </p15:sldGuideLst>
     </p:ext>
     <p:ext uri="GoogleSlidesCustomDataVersion2">
-      <go:slidesCustomData xmlns="" xmlns:mc="http://schemas.openxmlformats.org/markup-compatibility/2006" xmlns:mv="urn:schemas-microsoft-com:mac:vml" xmlns:c="http://schemas.openxmlformats.org/drawingml/2006/chart" xmlns:dgm="http://schemas.openxmlformats.org/drawingml/2006/diagram" xmlns:o="urn:schemas-microsoft-com:office:office" xmlns:v="urn:schemas-microsoft-com:vml" xmlns:pvml="urn:schemas-microsoft-com:office:powerpoint" xmlns:com="http://schemas.openxmlformats.org/drawingml/2006/compatibility" xmlns:p14="http://schemas.microsoft.com/office/powerpoint/2010/main" xmlns:p15="http://schemas.microsoft.com/office/powerpoint/2012/main" xmlns:ahyp="http://schemas.microsoft.com/office/drawing/2018/hyperlinkcolor" xmlns:go="http://customooxmlschemas.google.com/" r:id="rId25" roundtripDataSignature="AMtx7mhYCERjfTiog5M8ALqiUg2al05/tA=="/>
+      <go:slidesCustomData xmlns:go="http://customooxmlschemas.google.com/" xmlns:ahyp="http://schemas.microsoft.com/office/drawing/2018/hyperlinkcolor" xmlns:p15="http://schemas.microsoft.com/office/powerpoint/2012/main" xmlns:p14="http://schemas.microsoft.com/office/powerpoint/2010/main" xmlns:com="http://schemas.openxmlformats.org/drawingml/2006/compatibility" xmlns:pvml="urn:schemas-microsoft-com:office:powerpoint" xmlns:v="urn:schemas-microsoft-com:vml" xmlns:o="urn:schemas-microsoft-com:office:office" xmlns:dgm="http://schemas.openxmlformats.org/drawingml/2006/diagram" xmlns:c="http://schemas.openxmlformats.org/drawingml/2006/chart" xmlns:mv="urn:schemas-microsoft-com:mac:vml" xmlns:mc="http://schemas.openxmlformats.org/markup-compatibility/2006" xmlns="" r:id="rId25" roundtripDataSignature="AMtx7mhYCERjfTiog5M8ALqiUg2al05/tA=="/>
     </p:ext>
   </p:extLst>
 </p:presentation>
+</file>
+
+<file path=ppt/changesInfos/changesInfo1.xml><?xml version="1.0" encoding="utf-8"?>
+<pc:chgInfo xmlns:a="http://schemas.openxmlformats.org/drawingml/2006/main" xmlns:r="http://schemas.openxmlformats.org/officeDocument/2006/relationships" xmlns:ac="http://schemas.microsoft.com/office/drawing/2013/main/command" xmlns:pc="http://schemas.microsoft.com/office/powerpoint/2013/main/command">
+  <pc:docChgLst>
+    <pc:chgData name="Thomas MacPherson" userId="42c9da909567d9d7" providerId="LiveId" clId="{427B0E29-7DD1-4E2F-B77E-5696920B1BE2}"/>
+    <pc:docChg chg="modSld">
+      <pc:chgData name="Thomas MacPherson" userId="42c9da909567d9d7" providerId="LiveId" clId="{427B0E29-7DD1-4E2F-B77E-5696920B1BE2}" dt="2025-06-23T00:24:46.496" v="5" actId="20577"/>
+      <pc:docMkLst>
+        <pc:docMk/>
+      </pc:docMkLst>
+      <pc:sldChg chg="modSp mod">
+        <pc:chgData name="Thomas MacPherson" userId="42c9da909567d9d7" providerId="LiveId" clId="{427B0E29-7DD1-4E2F-B77E-5696920B1BE2}" dt="2025-06-23T00:24:46.496" v="5" actId="20577"/>
+        <pc:sldMkLst>
+          <pc:docMk/>
+          <pc:sldMk cId="0" sldId="256"/>
+        </pc:sldMkLst>
+        <pc:spChg chg="mod">
+          <ac:chgData name="Thomas MacPherson" userId="42c9da909567d9d7" providerId="LiveId" clId="{427B0E29-7DD1-4E2F-B77E-5696920B1BE2}" dt="2025-06-23T00:24:46.496" v="5" actId="20577"/>
+          <ac:spMkLst>
+            <pc:docMk/>
+            <pc:sldMk cId="0" sldId="256"/>
+            <ac:spMk id="50" creationId="{00000000-0000-0000-0000-000000000000}"/>
+          </ac:spMkLst>
+        </pc:spChg>
+      </pc:sldChg>
+    </pc:docChg>
+  </pc:docChgLst>
+</pc:chgInfo>
 </file>
 
 <file path=ppt/notesMasters/notesMaster1.xml><?xml version="1.0" encoding="utf-8"?>
@@ -8995,7 +9024,23 @@
                   <a:schemeClr val="tx1"/>
                 </a:solidFill>
               </a:rPr>
-              <a:t>However, a small subset of individual insiders generated significant alpha. We identified 388 “elite alpha insiders”, each with three or more purchases that produced raw six-month excess returns of 20% or more.</a:t>
+              <a:t>However, a small subset of individual insiders generated significant alpha. We </a:t>
+            </a:r>
+            <a:r>
+              <a:rPr lang="en" sz="1000">
+                <a:solidFill>
+                  <a:schemeClr val="tx1"/>
+                </a:solidFill>
+              </a:rPr>
+              <a:t>identified 169 </a:t>
+            </a:r>
+            <a:r>
+              <a:rPr lang="en" sz="1000" dirty="0">
+                <a:solidFill>
+                  <a:schemeClr val="tx1"/>
+                </a:solidFill>
+              </a:rPr>
+              <a:t>“elite alpha insiders”, each with three or more purchases that produced raw six-month excess returns of 20% or more.</a:t>
             </a:r>
             <a:endParaRPr dirty="0">
               <a:solidFill>

</xml_diff>